<commit_message>
Fix Week 8 typos
</commit_message>
<xml_diff>
--- a/files/inst414_spring2026/lectures/lecture_8b_decision_trees.pptx
+++ b/files/inst414_spring2026/lectures/lecture_8b_decision_trees.pptx
@@ -12509,8 +12509,8 @@
           </a:p>
         </p:txBody>
       </p:sp>
-      <mc:AlternateContent xmlns:mc="http://schemas.openxmlformats.org/markup-compatibility/2006" xmlns:a14="http://schemas.microsoft.com/office/drawing/2010/main">
-        <mc:Choice Requires="a14">
+      <mc:AlternateContent xmlns:mc="http://schemas.openxmlformats.org/markup-compatibility/2006">
+        <mc:Choice xmlns:a14="http://schemas.microsoft.com/office/drawing/2010/main" Requires="a14">
           <p:sp>
             <p:nvSpPr>
               <p:cNvPr id="3" name="Content Placeholder 2">
@@ -12703,7 +12703,7 @@
               <a:p>
                 <a:r>
                   <a:rPr lang="en-US" dirty="0"/>
-                  <a:t>Decisions Trees:</a:t>
+                  <a:t>Decision Trees:</a:t>
                 </a:r>
               </a:p>
               <a:p>
@@ -12718,7 +12718,15 @@
                 </a:r>
                 <a:r>
                   <a:rPr lang="en-US" dirty="0"/>
-                  <a:t> variable (and threshold) that bests separates 1s and 0s</a:t>
+                  <a:t> variable (and threshold) </a:t>
+                </a:r>
+                <a:r>
+                  <a:rPr lang="en-US"/>
+                  <a:t>that best </a:t>
+                </a:r>
+                <a:r>
+                  <a:rPr lang="en-US" dirty="0"/>
+                  <a:t>separates 1s and 0s</a:t>
                 </a:r>
               </a:p>
               <a:p>
@@ -12734,7 +12742,7 @@
             </p:txBody>
           </p:sp>
         </mc:Choice>
-        <mc:Fallback xmlns="">
+        <mc:Fallback>
           <p:sp>
             <p:nvSpPr>
               <p:cNvPr id="3" name="Content Placeholder 2">
@@ -12755,7 +12763,7 @@
               <a:blipFill>
                 <a:blip r:embed="rId2"/>
                 <a:stretch>
-                  <a:fillRect l="-1043" t="-3081"/>
+                  <a:fillRect l="-1043" t="-3361" r="-116"/>
                 </a:stretch>
               </a:blipFill>
             </p:spPr>

</xml_diff>